<commit_message>
Updated ZIPS to exclude non-Kitsap County
</commit_message>
<xml_diff>
--- a/presentation/kitsap_healthcare_access_equity_slidedeck.pptx
+++ b/presentation/kitsap_healthcare_access_equity_slidedeck.pptx
@@ -8398,8 +8398,8 @@
         </p:nvSpPr>
         <p:spPr>
           <a:xfrm>
-            <a:off x="8037476" y="2635522"/>
-            <a:ext cx="3657600" cy="2743200"/>
+            <a:off x="8037476" y="2546622"/>
+            <a:ext cx="3657600" cy="2923580"/>
           </a:xfrm>
           <a:prstGeom prst="roundRect">
             <a:avLst/>
@@ -8458,8 +8458,8 @@
         </p:nvSpPr>
         <p:spPr>
           <a:xfrm>
-            <a:off x="4281960" y="2635522"/>
-            <a:ext cx="3657600" cy="2743200"/>
+            <a:off x="4281960" y="2546621"/>
+            <a:ext cx="3657600" cy="2923581"/>
           </a:xfrm>
           <a:prstGeom prst="roundRect">
             <a:avLst/>
@@ -8518,8 +8518,8 @@
         </p:nvSpPr>
         <p:spPr>
           <a:xfrm>
-            <a:off x="528022" y="2646147"/>
-            <a:ext cx="3657600" cy="2732575"/>
+            <a:off x="528022" y="2557247"/>
+            <a:ext cx="3657600" cy="2923581"/>
           </a:xfrm>
           <a:prstGeom prst="roundRect">
             <a:avLst/>
@@ -8582,7 +8582,7 @@
         </p:nvSpPr>
         <p:spPr>
           <a:xfrm>
-            <a:off x="825500" y="2795183"/>
+            <a:off x="825500" y="2706283"/>
             <a:ext cx="3241388" cy="2583539"/>
           </a:xfrm>
         </p:spPr>
@@ -8618,7 +8618,7 @@
               <a:buNone/>
             </a:pPr>
             <a:r>
-              <a:rPr lang="en-US" sz="1800" dirty="0"/>
+              <a:rPr lang="en-US" sz="1700" dirty="0"/>
               <a:t>  • Population: 32,288 </a:t>
             </a:r>
           </a:p>
@@ -8627,7 +8627,7 @@
               <a:buNone/>
             </a:pPr>
             <a:r>
-              <a:rPr lang="en-US" sz="1800" dirty="0"/>
+              <a:rPr lang="en-US" sz="1700" dirty="0"/>
               <a:t>  • 1.86 providers per 10k </a:t>
             </a:r>
           </a:p>
@@ -8636,10 +8636,10 @@
               <a:buNone/>
             </a:pPr>
             <a:r>
-              <a:rPr lang="en-US" sz="1800" dirty="0"/>
+              <a:rPr lang="en-US" sz="1700" dirty="0"/>
               <a:t>  • 11.4% poverty rate</a:t>
             </a:r>
-            <a:endParaRPr lang="en-US" sz="1800" i="1" dirty="0"/>
+            <a:endParaRPr lang="en-US" sz="1700" i="1" dirty="0"/>
           </a:p>
         </p:txBody>
       </p:sp>
@@ -8687,7 +8687,7 @@
         </p:nvSpPr>
         <p:spPr>
           <a:xfrm>
-            <a:off x="4575865" y="2795183"/>
+            <a:off x="4575865" y="2706283"/>
             <a:ext cx="2964069" cy="2153593"/>
           </a:xfrm>
           <a:prstGeom prst="rect">
@@ -8889,7 +8889,7 @@
               <a:buNone/>
             </a:pPr>
             <a:r>
-              <a:rPr lang="en-US" sz="1800" dirty="0"/>
+              <a:rPr lang="en-US" sz="1700" dirty="0"/>
               <a:t>  • Population: 4,889 </a:t>
             </a:r>
           </a:p>
@@ -8898,7 +8898,7 @@
               <a:buNone/>
             </a:pPr>
             <a:r>
-              <a:rPr lang="en-US" sz="1800" dirty="0"/>
+              <a:rPr lang="en-US" sz="1700" dirty="0"/>
               <a:t>  • 0 providers </a:t>
             </a:r>
           </a:p>
@@ -8907,7 +8907,7 @@
               <a:buNone/>
             </a:pPr>
             <a:r>
-              <a:rPr lang="en-US" sz="1800" dirty="0"/>
+              <a:rPr lang="en-US" sz="1700" dirty="0"/>
               <a:t>  • 12.3% poverty rate</a:t>
             </a:r>
           </a:p>
@@ -8929,8 +8929,8 @@
         </p:nvSpPr>
         <p:spPr>
           <a:xfrm>
-            <a:off x="8333098" y="2795183"/>
-            <a:ext cx="3361978" cy="2153593"/>
+            <a:off x="8333098" y="2706283"/>
+            <a:ext cx="3361978" cy="2348317"/>
           </a:xfrm>
           <a:prstGeom prst="rect">
             <a:avLst/>
@@ -9114,7 +9114,7 @@
                   <a:srgbClr val="1B491D"/>
                 </a:solidFill>
               </a:rPr>
-              <a:t>98320 (Brinnon)</a:t>
+              <a:t>98637 (Port Orchard)</a:t>
             </a:r>
           </a:p>
           <a:p>
@@ -9123,7 +9123,7 @@
             </a:pPr>
             <a:r>
               <a:rPr lang="en-US" sz="1800" dirty="0"/>
-              <a:t>Older rural community with no healthcare facilities identified </a:t>
+              <a:t>Growing residential community with no healthcare facilities identified despite serving more than 31,000 residents.</a:t>
             </a:r>
           </a:p>
           <a:p>
@@ -9131,8 +9131,8 @@
               <a:buNone/>
             </a:pPr>
             <a:r>
-              <a:rPr lang="en-US" sz="1800" dirty="0"/>
-              <a:t>  • Population: 1,483 </a:t>
+              <a:rPr lang="en-US" sz="1700" dirty="0"/>
+              <a:t>  • Population: 31,186 </a:t>
             </a:r>
           </a:p>
           <a:p>
@@ -9140,8 +9140,8 @@
               <a:buNone/>
             </a:pPr>
             <a:r>
-              <a:rPr lang="en-US" sz="1800" dirty="0"/>
-              <a:t>  • Median age: 56.2 </a:t>
+              <a:rPr lang="en-US" sz="1700" dirty="0"/>
+              <a:t>  • 0 providers</a:t>
             </a:r>
           </a:p>
           <a:p>
@@ -9149,8 +9149,8 @@
               <a:buNone/>
             </a:pPr>
             <a:r>
-              <a:rPr lang="en-US" sz="1800" dirty="0"/>
-              <a:t>  • 0 providers</a:t>
+              <a:rPr lang="en-US" sz="1700" dirty="0"/>
+              <a:t>  • 6.9% poverty rate</a:t>
             </a:r>
           </a:p>
         </p:txBody>
@@ -9356,7 +9356,7 @@
         </p:nvSpPr>
         <p:spPr>
           <a:xfrm>
-            <a:off x="455238" y="1609047"/>
+            <a:off x="455238" y="1570947"/>
             <a:ext cx="11281525" cy="861774"/>
           </a:xfrm>
           <a:prstGeom prst="rect">
@@ -9383,12 +9383,8 @@
           <a:p>
             <a:pPr algn="ctr"/>
             <a:r>
-              <a:rPr lang="en-US" sz="1400" b="1" dirty="0"/>
-              <a:t>Although all three communities ranked among the highest priorities</a:t>
-            </a:r>
-            <a:r>
               <a:rPr lang="en-US" sz="1400" dirty="0"/>
-              <a:t>, they represent different patterns of potential healthcare access challenges.</a:t>
+              <a:t>Although all three communities ranked among the highest priorities, each illustrates a different healthcare access challenge.</a:t>
             </a:r>
           </a:p>
         </p:txBody>

</xml_diff>